<commit_message>
1.8.0: template email, paket React + Tailwind, template perjanjian
- email/: renderEmail tanpa dependensi (Node, Deno, browser), tabel inline aman di Gmail/Outlook, teks polos, isian di-escape; 9 template transaksional dan PNG maskot
- react/: komponen TSX di atas kelas kit, preset Tailwind v3 dan token v4 dari variabel kit, js/seal.d.ts
- dokumen: perjanjian kerja sama (PRJ) versi PDF dan Word
- Uji email.mjs dan react.mjs, dokumentasi AGENTS/DESIGN/README/skill

Co-Authored-By: Claude Opus 5.5 <noreply@anthropic.com>
Claude-Session: https://claude.ai/code/session_01H4ZVrZ9V3BgNkxuhZCNDSa
</commit_message>
<xml_diff>
--- a/dokumen/office/FUSIONIFY-Slide.pptx
+++ b/dokumen/office/FUSIONIFY-Slide.pptx
@@ -113,12 +113,12 @@
   <p:extLst>
     <p:ext uri="{521415D9-36F7-43E2-AB2F-B90AF26B5E84}">
       <p14:sectionLst xmlns:p14="http://schemas.microsoft.com/office/powerpoint/2010/main">
-        <p14:section name="Pembuka" id="{c15c4046-7975-09d7-4aeb-d4f8198590b8}">
+        <p14:section name="Pembuka" id="{4df0ae3f-3f33-b60a-ac1d-63531914ceab}">
           <p14:sldIdLst>
             <p14:sldId id="256"/>
           </p14:sldIdLst>
         </p14:section>
-        <p14:section name="Isi" id="{c1ec57ec-7921-70e2-585f-8f88e7d29738}">
+        <p14:section name="Isi" id="{a095a4e0-091a-a678-e88f-9995da40ee0b}">
           <p14:sldIdLst>
             <p14:sldId id="257"/>
             <p14:sldId id="258"/>
@@ -127,7 +127,7 @@
             <p14:sldId id="261"/>
           </p14:sldIdLst>
         </p14:section>
-        <p14:section name="Penutup" id="{b8998711-4f9b-4570-5b26-05ca10417b09}">
+        <p14:section name="Penutup" id="{25ab73cc-eec4-9b60-7e94-c9541afe09d7}">
           <p14:sldIdLst>
             <p14:sldId id="262"/>
           </p14:sldIdLst>

</xml_diff>

<commit_message>
1.10.2: kode nomor dokumen FDS diganti FI
Co-Authored-By: Claude Opus 5.5 <noreply@anthropic.com>
Claude-Session: https://claude.ai/code/session_01H4ZVrZ9V3BgNkxuhZCNDSa
</commit_message>
<xml_diff>
--- a/dokumen/office/FUSIONIFY-Slide.pptx
+++ b/dokumen/office/FUSIONIFY-Slide.pptx
@@ -113,12 +113,12 @@
   <p:extLst>
     <p:ext uri="{521415D9-36F7-43E2-AB2F-B90AF26B5E84}">
       <p14:sectionLst xmlns:p14="http://schemas.microsoft.com/office/powerpoint/2010/main">
-        <p14:section name="Pembuka" id="{4df0ae3f-3f33-b60a-ac1d-63531914ceab}">
+        <p14:section name="Pembuka" id="{f3b132cf-c430-b96a-f372-1c34799ba882}">
           <p14:sldIdLst>
             <p14:sldId id="256"/>
           </p14:sldIdLst>
         </p14:section>
-        <p14:section name="Isi" id="{a095a4e0-091a-a678-e88f-9995da40ee0b}">
+        <p14:section name="Isi" id="{ec409a9f-c2f9-a624-3a5c-354f422a67ee}">
           <p14:sldIdLst>
             <p14:sldId id="257"/>
             <p14:sldId id="258"/>
@@ -127,7 +127,7 @@
             <p14:sldId id="261"/>
           </p14:sldIdLst>
         </p14:section>
-        <p14:section name="Penutup" id="{25ab73cc-eec4-9b60-7e94-c9541afe09d7}">
+        <p14:section name="Penutup" id="{c75ddd34-6291-e6f8-92f7-99f42f4de0f0}">
           <p14:sldIdLst>
             <p14:sldId id="262"/>
           </p14:sldIdLst>

</xml_diff>